<commit_message>
docs(presentation): team roster on the title slide + final repo URL on the grader slide
Co-Authored-By: Claude Fable 5 <noreply@anthropic.com>
</commit_message>
<xml_diff>
--- a/presentation/munassiq-capstone.pptx
+++ b/presentation/munassiq-capstone.pptx
@@ -3373,7 +3373,7 @@
                 <a:ea typeface="Arial" pitchFamily="34" charset="-122"/>
                 <a:cs typeface="Arial" pitchFamily="34" charset="-120"/>
               </a:rPr>
-              <a:t>Abdulaziz Mulia (عبدالعزيز مُليا) — github.com/AK7Amin</a:t>
+              <a:t>Abdulaziz Khalid Mulia (leader) — github.com/AK7Amin</a:t>
             </a:r>
             <a:endParaRPr lang="en-US" sz="1600" dirty="0"/>
           </a:p>
@@ -3382,6 +3382,45 @@
       <p:sp>
         <p:nvSpPr>
           <p:cNvPr id="6" name="Text 4"/>
+          <p:cNvSpPr/>
+          <p:nvPr/>
+        </p:nvSpPr>
+        <p:spPr>
+          <a:xfrm>
+            <a:off x="502920" y="4526280"/>
+            <a:ext cx="10972800" cy="411480"/>
+          </a:xfrm>
+          <a:prstGeom prst="rect">
+            <a:avLst/>
+          </a:prstGeom>
+          <a:noFill/>
+          <a:ln/>
+        </p:spPr>
+        <p:txBody>
+          <a:bodyPr wrap="square" lIns="0" tIns="0" rIns="0" bIns="0" rtlCol="0" anchor="ctr"/>
+          <a:lstStyle/>
+          <a:p>
+            <a:pPr indent="0" marL="0">
+              <a:buNone/>
+            </a:pPr>
+            <a:r>
+              <a:rPr lang="en-US" sz="1300" dirty="0">
+                <a:solidFill>
+                  <a:srgbClr val="C9D3E8"/>
+                </a:solidFill>
+                <a:latin typeface="Calibri" pitchFamily="34" charset="0"/>
+                <a:ea typeface="Calibri" pitchFamily="34" charset="-122"/>
+                <a:cs typeface="Calibri" pitchFamily="34" charset="-120"/>
+              </a:rPr>
+              <a:t>Team: Ali Asiri · Faisal Abdullah Alhaqbani · Moayad Abdullah Badahdah · Ali Taha Alsahad · Zaid Al-Dowsari</a:t>
+            </a:r>
+            <a:endParaRPr lang="en-US" sz="1300" dirty="0"/>
+          </a:p>
+        </p:txBody>
+      </p:sp>
+      <p:sp>
+        <p:nvSpPr>
+          <p:cNvPr id="7" name="Text 5"/>
           <p:cNvSpPr/>
           <p:nvPr/>
         </p:nvSpPr>
@@ -13097,7 +13136,7 @@
                 <a:ea typeface="Arial" pitchFamily="34" charset="-122"/>
                 <a:cs typeface="Arial" pitchFamily="34" charset="-120"/>
               </a:rPr>
-              <a:t>github.com/AK7Amin/TestCapstone</a:t>
+              <a:t>github.com/AK7Amin/Capstone-SDAIA-Building-AI-Agents-Systems</a:t>
             </a:r>
             <a:endParaRPr lang="en-US" sz="1300" dirty="0"/>
           </a:p>

</xml_diff>